<commit_message>
Basically ok, should review, consider adding EPub3
</commit_message>
<xml_diff>
--- a/QuickIntroAccessibleMaths.pptx
+++ b/QuickIntroAccessibleMaths.pptx
@@ -322,7 +322,7 @@
           <a:p>
             <a:fld id="{241EB5C9-1307-BA42-ABA2-0BC069CD8E7F}" type="datetimeFigureOut">
               <a:rPr lang="en-US" smtClean="0"/>
-              <a:t>1/2/22</a:t>
+              <a:t>8/24/2026</a:t>
             </a:fld>
             <a:endParaRPr lang="en-US"/>
           </a:p>
@@ -490,7 +490,7 @@
           <a:p>
             <a:fld id="{241EB5C9-1307-BA42-ABA2-0BC069CD8E7F}" type="datetimeFigureOut">
               <a:rPr lang="en-US" smtClean="0"/>
-              <a:t>1/2/22</a:t>
+              <a:t>8/24/2026</a:t>
             </a:fld>
             <a:endParaRPr lang="en-US"/>
           </a:p>
@@ -668,7 +668,7 @@
           <a:p>
             <a:fld id="{241EB5C9-1307-BA42-ABA2-0BC069CD8E7F}" type="datetimeFigureOut">
               <a:rPr lang="en-US" smtClean="0"/>
-              <a:t>1/2/22</a:t>
+              <a:t>8/24/2026</a:t>
             </a:fld>
             <a:endParaRPr lang="en-US"/>
           </a:p>
@@ -785,35 +785,35 @@
           <a:p>
             <a:pPr lvl="0"/>
             <a:r>
-              <a:rPr lang="en-US"/>
+              <a:rPr lang="en-US" dirty="0"/>
               <a:t>Click to edit Master text styles</a:t>
             </a:r>
           </a:p>
           <a:p>
             <a:pPr lvl="1"/>
             <a:r>
-              <a:rPr lang="en-US"/>
+              <a:rPr lang="en-US" dirty="0"/>
               <a:t>Second level</a:t>
             </a:r>
           </a:p>
           <a:p>
             <a:pPr lvl="2"/>
             <a:r>
-              <a:rPr lang="en-US"/>
+              <a:rPr lang="en-US" dirty="0"/>
               <a:t>Third level</a:t>
             </a:r>
           </a:p>
           <a:p>
             <a:pPr lvl="3"/>
             <a:r>
-              <a:rPr lang="en-US"/>
+              <a:rPr lang="en-US" dirty="0"/>
               <a:t>Fourth level</a:t>
             </a:r>
           </a:p>
           <a:p>
             <a:pPr lvl="4"/>
             <a:r>
-              <a:rPr lang="en-US"/>
+              <a:rPr lang="en-US" dirty="0"/>
               <a:t>Fifth level</a:t>
             </a:r>
           </a:p>
@@ -836,7 +836,7 @@
           <a:p>
             <a:fld id="{241EB5C9-1307-BA42-ABA2-0BC069CD8E7F}" type="datetimeFigureOut">
               <a:rPr lang="en-US" smtClean="0"/>
-              <a:t>1/2/22</a:t>
+              <a:t>8/24/2026</a:t>
             </a:fld>
             <a:endParaRPr lang="en-US"/>
           </a:p>
@@ -1081,7 +1081,7 @@
           <a:p>
             <a:fld id="{241EB5C9-1307-BA42-ABA2-0BC069CD8E7F}" type="datetimeFigureOut">
               <a:rPr lang="en-US" smtClean="0"/>
-              <a:t>1/2/22</a:t>
+              <a:t>8/24/2026</a:t>
             </a:fld>
             <a:endParaRPr lang="en-US"/>
           </a:p>
@@ -1366,7 +1366,7 @@
           <a:p>
             <a:fld id="{241EB5C9-1307-BA42-ABA2-0BC069CD8E7F}" type="datetimeFigureOut">
               <a:rPr lang="en-US" smtClean="0"/>
-              <a:t>1/2/22</a:t>
+              <a:t>8/24/2026</a:t>
             </a:fld>
             <a:endParaRPr lang="en-US"/>
           </a:p>
@@ -1785,7 +1785,7 @@
           <a:p>
             <a:fld id="{241EB5C9-1307-BA42-ABA2-0BC069CD8E7F}" type="datetimeFigureOut">
               <a:rPr lang="en-US" smtClean="0"/>
-              <a:t>1/2/22</a:t>
+              <a:t>8/24/2026</a:t>
             </a:fld>
             <a:endParaRPr lang="en-US"/>
           </a:p>
@@ -1902,7 +1902,7 @@
           <a:p>
             <a:fld id="{241EB5C9-1307-BA42-ABA2-0BC069CD8E7F}" type="datetimeFigureOut">
               <a:rPr lang="en-US" smtClean="0"/>
-              <a:t>1/2/22</a:t>
+              <a:t>8/24/2026</a:t>
             </a:fld>
             <a:endParaRPr lang="en-US"/>
           </a:p>
@@ -1997,7 +1997,7 @@
           <a:p>
             <a:fld id="{241EB5C9-1307-BA42-ABA2-0BC069CD8E7F}" type="datetimeFigureOut">
               <a:rPr lang="en-US" smtClean="0"/>
-              <a:t>1/2/22</a:t>
+              <a:t>8/24/2026</a:t>
             </a:fld>
             <a:endParaRPr lang="en-US"/>
           </a:p>
@@ -2272,7 +2272,7 @@
           <a:p>
             <a:fld id="{241EB5C9-1307-BA42-ABA2-0BC069CD8E7F}" type="datetimeFigureOut">
               <a:rPr lang="en-US" smtClean="0"/>
-              <a:t>1/2/22</a:t>
+              <a:t>8/24/2026</a:t>
             </a:fld>
             <a:endParaRPr lang="en-US"/>
           </a:p>
@@ -2524,7 +2524,7 @@
           <a:p>
             <a:fld id="{241EB5C9-1307-BA42-ABA2-0BC069CD8E7F}" type="datetimeFigureOut">
               <a:rPr lang="en-US" smtClean="0"/>
-              <a:t>1/2/22</a:t>
+              <a:t>8/24/2026</a:t>
             </a:fld>
             <a:endParaRPr lang="en-US"/>
           </a:p>
@@ -2633,7 +2633,7 @@
           <a:lstStyle/>
           <a:p>
             <a:r>
-              <a:rPr lang="en-US"/>
+              <a:rPr dirty="0" lang="en-US"/>
               <a:t>Click to edit Master title style</a:t>
             </a:r>
           </a:p>
@@ -2666,35 +2666,35 @@
           <a:p>
             <a:pPr lvl="0"/>
             <a:r>
-              <a:rPr lang="en-US"/>
+              <a:rPr dirty="0" lang="en-US"/>
               <a:t>Click to edit Master text styles</a:t>
             </a:r>
           </a:p>
           <a:p>
             <a:pPr lvl="1"/>
             <a:r>
-              <a:rPr lang="en-US"/>
+              <a:rPr dirty="0" lang="en-US"/>
               <a:t>Second level</a:t>
             </a:r>
           </a:p>
           <a:p>
             <a:pPr lvl="2"/>
             <a:r>
-              <a:rPr lang="en-US"/>
+              <a:rPr dirty="0" lang="en-US"/>
               <a:t>Third level</a:t>
             </a:r>
           </a:p>
           <a:p>
             <a:pPr lvl="3"/>
             <a:r>
-              <a:rPr lang="en-US"/>
+              <a:rPr dirty="0" lang="en-US"/>
               <a:t>Fourth level</a:t>
             </a:r>
           </a:p>
           <a:p>
             <a:pPr lvl="4"/>
             <a:r>
-              <a:rPr lang="en-US"/>
+              <a:rPr dirty="0" lang="en-US"/>
               <a:t>Fifth level</a:t>
             </a:r>
           </a:p>
@@ -2735,7 +2735,7 @@
           <a:p>
             <a:fld id="{241EB5C9-1307-BA42-ABA2-0BC069CD8E7F}" type="datetimeFigureOut">
               <a:rPr lang="en-US" smtClean="0"/>
-              <a:t>1/2/22</a:t>
+              <a:t>8/24/2026</a:t>
             </a:fld>
             <a:endParaRPr lang="en-US"/>
           </a:p>
@@ -2864,7 +2864,7 @@
         </a:spcBef>
         <a:buFont typeface="Arial"/>
         <a:buChar char="•"/>
-        <a:defRPr kern="1200" sz="2400">
+        <a:defRPr kern="1200" sz="1600">
           <a:solidFill>
             <a:schemeClr val="tx1"/>
           </a:solidFill>
@@ -2879,7 +2879,7 @@
         </a:spcBef>
         <a:buFont typeface="Arial"/>
         <a:buChar char="–"/>
-        <a:defRPr kern="1200" sz="2100">
+        <a:defRPr kern="1200" sz="1600">
           <a:solidFill>
             <a:schemeClr val="tx1"/>
           </a:solidFill>
@@ -2894,7 +2894,7 @@
         </a:spcBef>
         <a:buFont typeface="Arial"/>
         <a:buChar char="•"/>
-        <a:defRPr kern="1200" sz="1800">
+        <a:defRPr kern="1200" sz="1200">
           <a:solidFill>
             <a:schemeClr val="tx1"/>
           </a:solidFill>
@@ -2909,7 +2909,7 @@
         </a:spcBef>
         <a:buFont typeface="Arial"/>
         <a:buChar char="–"/>
-        <a:defRPr kern="1200" sz="1500">
+        <a:defRPr kern="1200" sz="1100">
           <a:solidFill>
             <a:schemeClr val="tx1"/>
           </a:solidFill>
@@ -2924,7 +2924,7 @@
         </a:spcBef>
         <a:buFont typeface="Arial"/>
         <a:buChar char="»"/>
-        <a:defRPr kern="1200" sz="1500">
+        <a:defRPr kern="1200" sz="1100">
           <a:solidFill>
             <a:schemeClr val="tx1"/>
           </a:solidFill>
@@ -3815,15 +3815,6 @@
           <a:bodyPr/>
           <a:lstStyle/>
           <a:p>
-            <a:pPr lvl="0" indent="0" marL="0">
-              <a:buNone/>
-            </a:pPr>
-            <a:r>
-              <a:rPr/>
-              <a:t>EHC: CAN CAR CONVERT MATHTYPE BACK TO NORMAL WORD?</a:t>
-            </a:r>
-          </a:p>
-          <a:p>
             <a:pPr lvl="0"/>
             <a:r>
               <a:rPr>
@@ -3842,7 +3833,28 @@
               <a:rPr>
                 <a:hlinkClick r:id="rId3"/>
               </a:rPr>
-              <a:t>Transform Word to other formats</a:t>
+              <a:t>Central Access Reader</a:t>
+            </a:r>
+          </a:p>
+          <a:p>
+            <a:pPr lvl="1"/>
+            <a:r>
+              <a:rPr/>
+              <a:t>Transforms to specially set up HTML for screenreaders</a:t>
+            </a:r>
+          </a:p>
+          <a:p>
+            <a:pPr lvl="1"/>
+            <a:r>
+              <a:rPr/>
+              <a:t>Can output MP3</a:t>
+            </a:r>
+          </a:p>
+          <a:p>
+            <a:pPr lvl="1"/>
+            <a:r>
+              <a:rPr/>
+              <a:t>Can be used as text to speech software (but is not screenreader compatible)</a:t>
             </a:r>
           </a:p>
           <a:p>
@@ -3855,12 +3867,26 @@
             </a:r>
           </a:p>
           <a:p>
+            <a:pPr lvl="1"/>
+            <a:r>
+              <a:rPr/>
+              <a:t>Student can convert to MathType - supply standard format</a:t>
+            </a:r>
+          </a:p>
+          <a:p>
+            <a:pPr lvl="1"/>
+            <a:r>
+              <a:rPr/>
+              <a:t>Conversion back to Word is not possible in bulk</a:t>
+            </a:r>
+          </a:p>
+          <a:p>
             <a:pPr lvl="0" indent="0" marL="0">
               <a:buNone/>
             </a:pPr>
             <a:r>
               <a:rPr/>
-              <a:t>At the time of writing transforming from (any) PowerPoint is trickier. Best not to use this as a source format.</a:t>
+              <a:t>At the time of writing transforming from (any) PowerPoint is tricky. Best not to use this as a source format. If making slides, I would use Quarto (this!).</a:t>
             </a:r>
           </a:p>
         </p:txBody>
@@ -4669,7 +4695,7 @@
               <a:rPr>
                 <a:hlinkClick r:id="rId3"/>
               </a:rPr>
-              <a:t>Github repository</a:t>
+              <a:t>Github repository source - see qmd file</a:t>
             </a:r>
           </a:p>
         </p:txBody>

</xml_diff>

<commit_message>
Bit of reviewing, added BookML
</commit_message>
<xml_diff>
--- a/QuickIntroAccessibleMaths.pptx
+++ b/QuickIntroAccessibleMaths.pptx
@@ -3476,7 +3476,7 @@
             </a:pPr>
             <a:r>
               <a:rPr/>
-              <a:t>Not all reader assistive technology can access maths all formats!</a:t>
+              <a:t>Not all reader assistive technology can access maths in all formats!</a:t>
             </a:r>
           </a:p>
           <a:p>
@@ -3672,87 +3672,133 @@
           </a:p>
         </p:txBody>
       </p:sp>
-      <p:sp>
-        <p:nvSpPr>
-          <p:cNvPr id="3" name="Content Placeholder 2"/>
-          <p:cNvSpPr>
-            <a:spLocks noGrp="1"/>
-          </p:cNvSpPr>
-          <p:nvPr>
-            <p:ph idx="1"/>
-          </p:nvPr>
-        </p:nvSpPr>
-        <p:spPr/>
-        <p:txBody>
-          <a:bodyPr/>
-          <a:lstStyle/>
-          <a:p>
-            <a:pPr lvl="0"/>
-            <a:r>
-              <a:rPr/>
-              <a:t>Use the inbuilt Accessibility Checker and information on e.g. </a:t>
-            </a:r>
-            <a:r>
-              <a:rPr>
-                <a:hlinkClick r:id="rId2"/>
-              </a:rPr>
-              <a:t>Making your Word documents accessible</a:t>
-            </a:r>
-          </a:p>
-          <a:p>
-            <a:pPr lvl="0"/>
-            <a:r>
-              <a:rPr/>
-              <a:t>Write </a:t>
-            </a:r>
-            <a:r>
-              <a:rPr i="1"/>
-              <a:t>all</a:t>
-            </a:r>
-            <a:r>
-              <a:rPr/>
-              <a:t> mathematical text written using the MS 365 equation editor. E.g. if you are writing about the variable (x) or () it should be written as an equation. If you are writing (x^2) it should be written as an equation.</a:t>
-            </a:r>
-          </a:p>
-          <a:p>
-            <a:pPr lvl="1"/>
-            <a:r>
-              <a:rPr/>
-              <a:t>Never use insert symbol.</a:t>
-            </a:r>
-          </a:p>
-          <a:p>
-            <a:pPr lvl="1"/>
-            <a:r>
-              <a:rPr/>
-              <a:t>Never write superscripts, subscripts, fractions etc. using font or style changes and standard keyboard input alone</a:t>
-            </a:r>
-          </a:p>
-          <a:p>
-            <a:pPr lvl="1"/>
-            <a:r>
-              <a:rPr/>
-              <a:t>Never use an image of an equation.</a:t>
-            </a:r>
-          </a:p>
-          <a:p>
-            <a:pPr lvl="0"/>
-            <a:r>
-              <a:rPr/>
-              <a:t>Use Review -&gt; Read Aloud (Alt + Ctrl + Space) to check the maths</a:t>
-            </a:r>
-          </a:p>
-          <a:p>
-            <a:pPr lvl="0"/>
-            <a:r>
-              <a:rPr>
-                <a:hlinkClick r:id="rId3"/>
-              </a:rPr>
-              <a:t>Quick example</a:t>
-            </a:r>
-          </a:p>
-        </p:txBody>
-      </p:sp>
+      <mc:AlternateContent xmlns:mc="http://schemas.openxmlformats.org/markup-compatibility/2006">
+        <mc:Choice xmlns:a14="http://schemas.microsoft.com/office/drawing/2010/main" Requires="a14">
+          <p:sp>
+            <p:nvSpPr>
+              <p:cNvPr id="3" name="Content Placeholder 2"/>
+              <p:cNvSpPr>
+                <a:spLocks noGrp="1"/>
+              </p:cNvSpPr>
+              <p:nvPr>
+                <p:ph idx="1"/>
+              </p:nvPr>
+            </p:nvSpPr>
+            <p:spPr/>
+            <p:txBody>
+              <a:bodyPr/>
+              <a:lstStyle/>
+              <a:p>
+                <a:pPr lvl="0"/>
+                <a:r>
+                  <a:rPr/>
+                  <a:t>Use the inbuilt Accessibility Checker and information on e.g. </a:t>
+                </a:r>
+                <a:r>
+                  <a:rPr>
+                    <a:hlinkClick r:id="rId2"/>
+                  </a:rPr>
+                  <a:t>Making your Word documents accessible</a:t>
+                </a:r>
+              </a:p>
+              <a:p>
+                <a:pPr lvl="0"/>
+                <a:r>
+                  <a:rPr/>
+                  <a:t>Write </a:t>
+                </a:r>
+                <a:r>
+                  <a:rPr i="1"/>
+                  <a:t>all</a:t>
+                </a:r>
+                <a:r>
+                  <a:rPr/>
+                  <a:t> mathematical text written using the MS 365 equation editor. E.g. if you are writing about the variable (</a:t>
+                </a:r>
+                <a14:m>
+                  <m:oMath xmlns:m="http://schemas.openxmlformats.org/officeDocument/2006/math">
+                    <m:r>
+                      <m:t>x</m:t>
+                    </m:r>
+                  </m:oMath>
+                </a14:m>
+                <a:r>
+                  <a:rPr/>
+                  <a:t>) or (</a:t>
+                </a:r>
+                <a14:m>
+                  <m:oMath xmlns:m="http://schemas.openxmlformats.org/officeDocument/2006/math">
+                    <m:r>
+                      <m:t>θ</m:t>
+                    </m:r>
+                  </m:oMath>
+                </a14:m>
+                <a:r>
+                  <a:rPr/>
+                  <a:t>) it should be written as an equation. If you are writing (</a:t>
+                </a:r>
+                <a14:m>
+                  <m:oMath xmlns:m="http://schemas.openxmlformats.org/officeDocument/2006/math">
+                    <m:sSup>
+                      <m:e>
+                        <m:r>
+                          <m:t>x</m:t>
+                        </m:r>
+                      </m:e>
+                      <m:sup>
+                        <m:r>
+                          <m:t>2</m:t>
+                        </m:r>
+                      </m:sup>
+                    </m:sSup>
+                  </m:oMath>
+                </a14:m>
+                <a:r>
+                  <a:rPr/>
+                  <a:t>) it should be written as an equation.</a:t>
+                </a:r>
+              </a:p>
+              <a:p>
+                <a:pPr lvl="1"/>
+                <a:r>
+                  <a:rPr/>
+                  <a:t>Never use insert symbol.</a:t>
+                </a:r>
+              </a:p>
+              <a:p>
+                <a:pPr lvl="1"/>
+                <a:r>
+                  <a:rPr/>
+                  <a:t>Never write superscripts, subscripts, fractions etc. using font or style changes and standard keyboard input alone</a:t>
+                </a:r>
+              </a:p>
+              <a:p>
+                <a:pPr lvl="1"/>
+                <a:r>
+                  <a:rPr/>
+                  <a:t>Never use an image of an equation.</a:t>
+                </a:r>
+              </a:p>
+              <a:p>
+                <a:pPr lvl="0"/>
+                <a:r>
+                  <a:rPr/>
+                  <a:t>Use Review -&gt; Read Aloud (Alt + Ctrl + Space) to check the maths</a:t>
+                </a:r>
+              </a:p>
+              <a:p>
+                <a:pPr lvl="0"/>
+                <a:r>
+                  <a:rPr>
+                    <a:hlinkClick r:id="rId3"/>
+                  </a:rPr>
+                  <a:t>Quick example</a:t>
+                </a:r>
+              </a:p>
+            </p:txBody>
+          </p:sp>
+        </mc:Choice>
+      </mc:AlternateContent>
     </p:spTree>
   </p:cSld>
 </p:sld>
@@ -4176,99 +4222,96 @@
             </a:r>
             <a:r>
               <a:rPr/>
-              <a:t> or </a:t>
+              <a:t>, </a:t>
             </a:r>
             <a:r>
               <a:rPr>
                 <a:hlinkClick r:id="rId3"/>
               </a:rPr>
-              <a:t>lwarp</a:t>
-            </a:r>
-          </a:p>
-          <a:p>
-            <a:pPr lvl="1"/>
-            <a:r>
-              <a:rPr/>
-              <a:t>What happens depends on what you are doing in LaTeX</a:t>
-            </a:r>
-          </a:p>
-          <a:p>
-            <a:pPr lvl="1"/>
-            <a:r>
-              <a:rPr/>
-              <a:t>Keep your preamble </a:t>
-            </a:r>
-            <a:r>
-              <a:rPr b="1"/>
-              <a:t>clean</a:t>
-            </a:r>
-            <a:r>
-              <a:rPr/>
-              <a:t>, start with a minimal document, add in sections recompiling to all required output formats after each addition</a:t>
-            </a:r>
-          </a:p>
-          <a:p>
-            <a:pPr lvl="1"/>
-            <a:r>
-              <a:rPr/>
-              <a:t>Some documents cannot be converted</a:t>
-            </a:r>
-          </a:p>
-          <a:p>
-            <a:pPr lvl="1"/>
-            <a:r>
-              <a:rPr b="1"/>
-              <a:t>No known Beamer solution</a:t>
-            </a:r>
-            <a:r>
-              <a:rPr/>
-              <a:t> at time of writing</a:t>
-            </a:r>
-          </a:p>
-          <a:p>
-            <a:pPr lvl="0"/>
-            <a:r>
-              <a:rPr/>
-              <a:t>Work in a Markdown format, using LaTeX for equations, with HTML has the primary output (can also output LaTeX/PDF); can create slides and single-source slides and documents (like Beamer)</a:t>
-            </a:r>
-          </a:p>
-          <a:p>
-            <a:pPr lvl="1"/>
+              <a:t>BookML</a:t>
+            </a:r>
+            <a:r>
+              <a:rPr/>
+              <a:t> or </a:t>
+            </a:r>
             <a:r>
               <a:rPr>
                 <a:hlinkClick r:id="rId4"/>
               </a:rPr>
-              <a:t>Quarto</a:t>
-            </a:r>
-            <a:r>
-              <a:rPr/>
-              <a:t> is recommended in most cases</a:t>
-            </a:r>
-          </a:p>
-          <a:p>
-            <a:pPr lvl="2"/>
+              <a:t>lwarp</a:t>
+            </a:r>
+          </a:p>
+          <a:p>
+            <a:pPr lvl="1"/>
+            <a:r>
+              <a:rPr/>
+              <a:t>What happens depends on what you are doing in LaTeX</a:t>
+            </a:r>
+          </a:p>
+          <a:p>
+            <a:pPr lvl="1"/>
+            <a:r>
+              <a:rPr/>
+              <a:t>Keep your preamble </a:t>
+            </a:r>
+            <a:r>
+              <a:rPr b="1"/>
+              <a:t>clean</a:t>
+            </a:r>
+            <a:r>
+              <a:rPr/>
+              <a:t>, start with a minimal document, add in sections recompiling to all required output formats after each addition</a:t>
+            </a:r>
+          </a:p>
+          <a:p>
+            <a:pPr lvl="1"/>
+            <a:r>
+              <a:rPr/>
+              <a:t>Some documents cannot be converted</a:t>
+            </a:r>
+          </a:p>
+          <a:p>
+            <a:pPr lvl="1"/>
+            <a:r>
+              <a:rPr b="1"/>
+              <a:t>No known Beamer solution</a:t>
+            </a:r>
+            <a:r>
+              <a:rPr/>
+              <a:t> at time of writing</a:t>
+            </a:r>
+          </a:p>
+          <a:p>
+            <a:pPr lvl="0"/>
+            <a:r>
+              <a:rPr/>
+              <a:t>Work in a Markdown format, using LaTeX for equations, with HTML has the primary output (can also output LaTeX/PDF); can create slides and single-source slides and documents (like Beamer)</a:t>
+            </a:r>
+          </a:p>
+          <a:p>
+            <a:pPr lvl="1"/>
             <a:r>
               <a:rPr>
                 <a:hlinkClick r:id="rId5"/>
               </a:rPr>
-              <a:t>Bookdown</a:t>
-            </a:r>
-            <a:r>
-              <a:rPr/>
-              <a:t> continues to be fine but start new projects in Quarto</a:t>
-            </a:r>
-          </a:p>
-          <a:p>
-            <a:pPr lvl="1"/>
+              <a:t>Quarto</a:t>
+            </a:r>
+            <a:r>
+              <a:rPr/>
+              <a:t> is recommended in most cases</a:t>
+            </a:r>
+          </a:p>
+          <a:p>
+            <a:pPr lvl="2"/>
             <a:r>
               <a:rPr>
                 <a:hlinkClick r:id="rId6"/>
               </a:rPr>
-              <a:t>RMarkdown</a:t>
-            </a:r>
-            <a:r>
-              <a:rPr/>
-              <a:t> can be a helpful starting point for those completely new</a:t>
+              <a:t>Bookdown</a:t>
+            </a:r>
+            <a:r>
+              <a:rPr/>
+              <a:t> continues to be fine but start new projects in Quarto</a:t>
             </a:r>
           </a:p>
           <a:p>
@@ -4277,11 +4320,24 @@
               <a:rPr>
                 <a:hlinkClick r:id="rId7"/>
               </a:rPr>
+              <a:t>RMarkdown</a:t>
+            </a:r>
+            <a:r>
+              <a:rPr/>
+              <a:t> can be a helpful starting point for those completely new</a:t>
+            </a:r>
+          </a:p>
+          <a:p>
+            <a:pPr lvl="1"/>
+            <a:r>
+              <a:rPr>
+                <a:hlinkClick r:id="rId8"/>
+              </a:rPr>
               <a:t>Clavertondown</a:t>
             </a:r>
             <a:r>
               <a:rPr/>
-              <a:t>, built on top of RMarkdown and Bookdown; should only be used if the other formats can’t meet needs</a:t>
+              <a:t>, built using RMarkdown and Bookdown; only if other methods can’t meet needs</a:t>
             </a:r>
           </a:p>
         </p:txBody>

</xml_diff>

<commit_message>
Tidied up, slight re-ordering of pdf information, added formats
</commit_message>
<xml_diff>
--- a/QuickIntroAccessibleMaths.pptx
+++ b/QuickIntroAccessibleMaths.pptx
@@ -3343,7 +3343,7 @@
             </a:pPr>
             <a:r>
               <a:rPr/>
-              <a:t>Only four formats of mathematical text are technically accessible:</a:t>
+              <a:t>Until all this work is finished for PDF, only four formats of mathematical text are technically accessible:</a:t>
             </a:r>
           </a:p>
           <a:p>
@@ -3490,7 +3490,7 @@
             <a:pPr lvl="0"/>
             <a:r>
               <a:rPr/>
-              <a:t>Some cannot not be transformed easily to others</a:t>
+              <a:t>Some formats cannot not be transformed easily to others</a:t>
             </a:r>
           </a:p>
           <a:p>
@@ -3508,61 +3508,51 @@
             </a:pPr>
             <a:r>
               <a:rPr/>
-              <a:t>For authors using the LaTeX scientific document preparation system none of the above formats are native outputs</a:t>
+              <a:t>For authors using the LaTeX scientific document preparation system none of the above formats are native outputs. </a:t>
+            </a:r>
+            <a:r>
+              <a:rPr b="1"/>
+              <a:t>And</a:t>
+            </a:r>
+            <a:r>
+              <a:rPr/>
+              <a:t> if a student can’t make their own clear print </a:t>
+            </a:r>
+            <a:r>
+              <a:rPr b="1"/>
+              <a:t>and print it</a:t>
+            </a:r>
+            <a:r>
+              <a:rPr/>
+              <a:t> you also may need to supply variants on inaccessible PDF!</a:t>
+            </a:r>
+          </a:p>
+          <a:p>
+            <a:pPr lvl="0"/>
+            <a:r>
+              <a:rPr/>
+              <a:t>Not all accessibility is about technical access</a:t>
+            </a:r>
+          </a:p>
+          <a:p>
+            <a:pPr lvl="0"/>
+            <a:r>
+              <a:rPr/>
+              <a:t>Clear print</a:t>
             </a:r>
             <a:r>
               <a:rPr baseline="30000">
                 <a:hlinkClick r:id="rId2" action="ppaction://hlinksldjump"/>
               </a:rPr>
-              <a:t>3</a:t>
-            </a:r>
-            <a:r>
-              <a:rPr/>
-              <a:t>. </a:t>
-            </a:r>
-            <a:r>
-              <a:rPr b="1"/>
-              <a:t>And</a:t>
-            </a:r>
-            <a:r>
-              <a:rPr/>
-              <a:t> if a student can’t make their own clear print </a:t>
-            </a:r>
-            <a:r>
-              <a:rPr b="1"/>
-              <a:t>and print it</a:t>
-            </a:r>
-            <a:r>
-              <a:rPr/>
-              <a:t> you also may need to supply variants on inaccessible PDF!</a:t>
-            </a:r>
-          </a:p>
-          <a:p>
-            <a:pPr lvl="0"/>
-            <a:r>
-              <a:rPr/>
-              <a:t>Not all accessibility is about technical access</a:t>
-            </a:r>
-          </a:p>
-          <a:p>
-            <a:pPr lvl="0"/>
-            <a:r>
-              <a:rPr/>
-              <a:t>Clear print</a:t>
+              <a:t>4</a:t>
+            </a:r>
+            <a:r>
+              <a:rPr/>
+              <a:t> PDF is selected most often by disabled students in the Department of Mathematical Sciences at the University of Bath</a:t>
             </a:r>
             <a:r>
               <a:rPr baseline="30000">
                 <a:hlinkClick r:id="rId3" action="ppaction://hlinksldjump"/>
-              </a:rPr>
-              <a:t>4</a:t>
-            </a:r>
-            <a:r>
-              <a:rPr/>
-              <a:t> PDF is selected most often by disabled students in the Department of Mathematical Sciences at the University of Bath</a:t>
-            </a:r>
-            <a:r>
-              <a:rPr baseline="30000">
-                <a:hlinkClick r:id="rId4" action="ppaction://hlinksldjump"/>
               </a:rPr>
               <a:t>5</a:t>
             </a:r>
@@ -3708,7 +3698,7 @@
                   <a:t>Write </a:t>
                 </a:r>
                 <a:r>
-                  <a:rPr i="1"/>
+                  <a:rPr b="1" i="1"/>
                   <a:t>all</a:t>
                 </a:r>
                 <a:r>
@@ -3932,7 +3922,7 @@
             </a:pPr>
             <a:r>
               <a:rPr/>
-              <a:t>At the time of writing transforming from (any) PowerPoint is tricky. Best not to use this as a source format. If making slides, I would use Quarto (this!).</a:t>
+              <a:t>At the time of writing transforming from (any) PowerPoint is tricky. Best not to use this as a source format. If making slides, I would use Quarto (used to make this!).</a:t>
             </a:r>
           </a:p>
         </p:txBody>
@@ -4117,7 +4107,7 @@
                 <a:pPr lvl="1"/>
                 <a:r>
                   <a:rPr/>
-                  <a:t>Structural integrity enables assistive technology including text-to-speech, screenreaders, electronic Braille</a:t>
+                  <a:t>Encoded structure enables assistive technology including text-to-speech, screenreaders, electronic Braille</a:t>
                 </a:r>
               </a:p>
               <a:p>
@@ -4140,7 +4130,17 @@
                 </a:pPr>
                 <a:r>
                   <a:rPr/>
-                  <a:t>We recommend using MathJax 2.7.9 or MathJax 4.* as MathJax 3.x does not enable reflow on zoom.</a:t>
+                  <a:t>We recommend using MathJax 2.7.9 or </a:t>
+                </a:r>
+                <a:r>
+                  <a:rPr>
+                    <a:hlinkClick r:id="rId3"/>
+                  </a:rPr>
+                  <a:t>MathJax 4.* as MathJax 3.* does not enable reflow on zoom</a:t>
+                </a:r>
+                <a:r>
+                  <a:rPr/>
+                  <a:t> (a requirement for WCAG 2.2 AA).</a:t>
                 </a:r>
               </a:p>
             </p:txBody>
@@ -4212,119 +4212,116 @@
             <a:pPr lvl="0"/>
             <a:r>
               <a:rPr/>
-              <a:t>Attempt to transform the LaTeX to HTML with MathJax using </a:t>
-            </a:r>
-            <a:r>
-              <a:rPr>
-                <a:hlinkClick r:id="rId2"/>
+              <a:t>Attempt to transform the LaTeX</a:t>
+            </a:r>
+            <a:r>
+              <a:rPr baseline="30000">
+                <a:hlinkClick r:id="rId2" action="ppaction://hlinksldjump"/>
               </a:rPr>
-              <a:t>Chirun</a:t>
-            </a:r>
-            <a:r>
-              <a:rPr/>
-              <a:t>, </a:t>
+              <a:t>6</a:t>
+            </a:r>
+            <a:r>
+              <a:rPr/>
+              <a:t> to HTML with MathJax using </a:t>
             </a:r>
             <a:r>
               <a:rPr>
                 <a:hlinkClick r:id="rId3"/>
               </a:rPr>
-              <a:t>BookML</a:t>
-            </a:r>
-            <a:r>
-              <a:rPr/>
-              <a:t> or </a:t>
+              <a:t>Chirun</a:t>
+            </a:r>
+            <a:r>
+              <a:rPr/>
+              <a:t>, </a:t>
             </a:r>
             <a:r>
               <a:rPr>
                 <a:hlinkClick r:id="rId4"/>
               </a:rPr>
-              <a:t>lwarp</a:t>
-            </a:r>
-          </a:p>
-          <a:p>
-            <a:pPr lvl="1"/>
-            <a:r>
-              <a:rPr/>
-              <a:t>What happens depends on what you are doing in LaTeX</a:t>
-            </a:r>
-          </a:p>
-          <a:p>
-            <a:pPr lvl="1"/>
-            <a:r>
-              <a:rPr/>
-              <a:t>Keep your preamble </a:t>
-            </a:r>
-            <a:r>
-              <a:rPr b="1"/>
-              <a:t>clean</a:t>
-            </a:r>
-            <a:r>
-              <a:rPr/>
-              <a:t>, start with a minimal document, add in sections recompiling to all required output formats after each addition</a:t>
-            </a:r>
-          </a:p>
-          <a:p>
-            <a:pPr lvl="1"/>
-            <a:r>
-              <a:rPr/>
-              <a:t>Some documents cannot be converted</a:t>
-            </a:r>
-          </a:p>
-          <a:p>
-            <a:pPr lvl="1"/>
-            <a:r>
-              <a:rPr b="1"/>
-              <a:t>No known Beamer solution</a:t>
-            </a:r>
-            <a:r>
-              <a:rPr/>
-              <a:t> at time of writing</a:t>
-            </a:r>
-          </a:p>
-          <a:p>
-            <a:pPr lvl="0"/>
-            <a:r>
-              <a:rPr/>
-              <a:t>Work in a Markdown format, using LaTeX for equations, with HTML has the primary output (can also output LaTeX/PDF); can create slides and single-source slides and documents (like Beamer)</a:t>
-            </a:r>
-          </a:p>
-          <a:p>
-            <a:pPr lvl="1"/>
+              <a:t>BookML</a:t>
+            </a:r>
+            <a:r>
+              <a:rPr/>
+              <a:t> or </a:t>
+            </a:r>
             <a:r>
               <a:rPr>
                 <a:hlinkClick r:id="rId5"/>
               </a:rPr>
-              <a:t>Quarto</a:t>
-            </a:r>
-            <a:r>
-              <a:rPr/>
-              <a:t> is recommended in most cases</a:t>
-            </a:r>
-          </a:p>
-          <a:p>
-            <a:pPr lvl="2"/>
+              <a:t>lwarp</a:t>
+            </a:r>
+          </a:p>
+          <a:p>
+            <a:pPr lvl="1"/>
+            <a:r>
+              <a:rPr/>
+              <a:t>What happens depends on what you are doing in LaTeX</a:t>
+            </a:r>
+          </a:p>
+          <a:p>
+            <a:pPr lvl="1"/>
+            <a:r>
+              <a:rPr/>
+              <a:t>Keep your preamble </a:t>
+            </a:r>
+            <a:r>
+              <a:rPr b="1"/>
+              <a:t>clean</a:t>
+            </a:r>
+            <a:r>
+              <a:rPr/>
+              <a:t>, start with a minimal document, add in sections recompiling to all required output formats after each addition</a:t>
+            </a:r>
+          </a:p>
+          <a:p>
+            <a:pPr lvl="1"/>
+            <a:r>
+              <a:rPr/>
+              <a:t>Some documents cannot be converted</a:t>
+            </a:r>
+          </a:p>
+          <a:p>
+            <a:pPr lvl="1"/>
+            <a:r>
+              <a:rPr b="1"/>
+              <a:t>I don’t know of a Beamer solution</a:t>
+            </a:r>
+            <a:r>
+              <a:rPr/>
+              <a:t> at time of writing</a:t>
+            </a:r>
+          </a:p>
+          <a:p>
+            <a:pPr lvl="0"/>
+            <a:r>
+              <a:rPr/>
+              <a:t>Work in a Markdown format, using LaTeX for equations, with HTML has the primary output (can also output LaTeX/PDF); can create slides and single-source slides and documents (like Beamer)</a:t>
+            </a:r>
+          </a:p>
+          <a:p>
+            <a:pPr lvl="1"/>
             <a:r>
               <a:rPr>
                 <a:hlinkClick r:id="rId6"/>
               </a:rPr>
-              <a:t>Bookdown</a:t>
-            </a:r>
-            <a:r>
-              <a:rPr/>
-              <a:t> continues to be fine but start new projects in Quarto</a:t>
-            </a:r>
-          </a:p>
-          <a:p>
-            <a:pPr lvl="1"/>
+              <a:t>Quarto</a:t>
+            </a:r>
+            <a:r>
+              <a:rPr/>
+              <a:t> is recommended in most cases</a:t>
+            </a:r>
+          </a:p>
+          <a:p>
+            <a:pPr lvl="2"/>
             <a:r>
               <a:rPr>
                 <a:hlinkClick r:id="rId7"/>
               </a:rPr>
-              <a:t>RMarkdown</a:t>
-            </a:r>
-            <a:r>
-              <a:rPr/>
-              <a:t> can be a helpful starting point for those completely new</a:t>
+              <a:t>Bookdown</a:t>
+            </a:r>
+            <a:r>
+              <a:rPr/>
+              <a:t> continues to be fine but start new projects in Quarto</a:t>
             </a:r>
           </a:p>
           <a:p>
@@ -4332,6 +4329,19 @@
             <a:r>
               <a:rPr>
                 <a:hlinkClick r:id="rId8"/>
+              </a:rPr>
+              <a:t>RMarkdown</a:t>
+            </a:r>
+            <a:r>
+              <a:rPr/>
+              <a:t> can be a helpful starting point for those completely new</a:t>
+            </a:r>
+          </a:p>
+          <a:p>
+            <a:pPr lvl="1"/>
+            <a:r>
+              <a:rPr>
+                <a:hlinkClick r:id="rId9"/>
               </a:rPr>
               <a:t>Clavertondown</a:t>
             </a:r>
@@ -4841,7 +4851,27 @@
             </a:pPr>
             <a:r>
               <a:rPr sz="1800"/>
-              <a:t>3. Work is ongoing to create a version of LaTeX, extra encoding within an adapted PDF </a:t>
+              <a:t>3. Work is ongoing to add encoding within a new PDF standard (PDF/UA-2 and WTPDF (Well-Tagged PDF) standards), </a:t>
+            </a:r>
+            <a:r>
+              <a:rPr sz="1800">
+                <a:hlinkClick r:id="rId2"/>
+              </a:rPr>
+              <a:t>create a version of LaTeX which can do this</a:t>
+            </a:r>
+            <a:r>
+              <a:rPr sz="1800"/>
+              <a:t> (itself, a multi-year project </a:t>
+            </a:r>
+            <a:r>
+              <a:rPr sz="1800">
+                <a:hlinkClick r:id="rId3"/>
+              </a:rPr>
+              <a:t>currently in stage 4 of enabling package authors to apply changes</a:t>
+            </a:r>
+            <a:r>
+              <a:rPr sz="1800"/>
+              <a:t>), </a:t>
             </a:r>
             <a:r>
               <a:rPr sz="1800" b="1"/>
@@ -4849,7 +4879,34 @@
             </a:r>
             <a:r>
               <a:rPr sz="1800"/>
-              <a:t> software which works with the extra encoding. In the meantime we need to either convert the LaTeX to other formats or switch to a different scientific document preparation system. It is </a:t>
+              <a:t> software which works with the extra encoding. The assistive technology vendors would then also need to support all of this. In the meantime we need to either convert the LaTeX to other formats or switch to a different scientific document preparation system.</a:t>
+            </a:r>
+          </a:p>
+          <a:p>
+            <a:pPr lvl="0" indent="0" marL="0">
+              <a:buNone/>
+            </a:pPr>
+            <a:r>
+              <a:rPr sz="1800"/>
+              <a:t>4. Adhering as closely as possible to RNIB clear print guidelines</a:t>
+            </a:r>
+          </a:p>
+          <a:p>
+            <a:pPr lvl="0" indent="0" marL="0">
+              <a:buNone/>
+            </a:pPr>
+            <a:r>
+              <a:rPr sz="1800"/>
+              <a:t>5. Last year we had to assist an author to create a printable PDF for a disabled student after the author had made a whole (and completely technically accessible) course using ProTeXt - but couldn’t get PDF working and the HTML produced poor print output…</a:t>
+            </a:r>
+          </a:p>
+          <a:p>
+            <a:pPr lvl="0" indent="0" marL="0">
+              <a:buNone/>
+            </a:pPr>
+            <a:r>
+              <a:rPr sz="1800"/>
+              <a:t>6. It is </a:t>
             </a:r>
             <a:r>
               <a:rPr sz="1800" b="1"/>
@@ -4858,24 +4915,6 @@
             <a:r>
               <a:rPr sz="1800"/>
               <a:t> to convert LaTeX to html in the general case. It is easy to ‘fall out’ of the convertible subset without realising or knowing why, the addition of a package, change of preamble order, use of a seemingly innocent command…</a:t>
-            </a:r>
-          </a:p>
-          <a:p>
-            <a:pPr lvl="0" indent="0" marL="0">
-              <a:buNone/>
-            </a:pPr>
-            <a:r>
-              <a:rPr sz="1800"/>
-              <a:t>4. Adhering as closely as possible to RNIB clear print guidelines</a:t>
-            </a:r>
-          </a:p>
-          <a:p>
-            <a:pPr lvl="0" indent="0" marL="0">
-              <a:buNone/>
-            </a:pPr>
-            <a:r>
-              <a:rPr sz="1800"/>
-              <a:t>5. Last year we had to assist an author to create a printable PDF for a disabled student after the author had made a whole (and completely technically accessible) course using ProTeXt - but couldn’t get PDF working and the HTML produced poor print output…</a:t>
             </a:r>
           </a:p>
         </p:txBody>
@@ -5529,7 +5568,17 @@
             </a:pPr>
             <a:r>
               <a:rPr/>
-              <a:t>Can we not solve this by ensuring that the PDF is accessible? Unfortunately, the answer is no. The act of creating the PDF destroys the structure of mathematical, and similar, expressions. Reflow on a small screen produces…</a:t>
+              <a:t>Can we not solve this by ensuring that the PDF is accessible? Unfortunately, the answer is currently, not yet</a:t>
+            </a:r>
+            <a:r>
+              <a:rPr baseline="30000">
+                <a:hlinkClick r:id="rId2" action="ppaction://hlinksldjump"/>
+              </a:rPr>
+              <a:t>3</a:t>
+            </a:r>
+            <a:r>
+              <a:rPr/>
+              <a:t>. In current software and typically in-use PDF standards, the act of creating the PDF destroys the structure of mathematical, and similar, expressions. Reflow on a small screen produces…</a:t>
             </a:r>
           </a:p>
         </p:txBody>
@@ -5543,14 +5592,14 @@
           <p:nvPr/>
         </p:nvPicPr>
         <p:blipFill>
-          <a:blip r:embed="rId2"/>
+          <a:blip r:embed="rId3"/>
           <a:stretch>
             <a:fillRect/>
           </a:stretch>
         </p:blipFill>
         <p:spPr bwMode="auto">
           <a:xfrm>
-            <a:off x="3568700" y="1041400"/>
+            <a:off x="3568700" y="787400"/>
             <a:ext cx="5105400" cy="2692400"/>
           </a:xfrm>
           <a:prstGeom prst="rect">
@@ -5564,6 +5613,36 @@
           </a:ln>
         </p:spPr>
       </p:pic>
+      <p:sp>
+        <p:nvSpPr>
+          <p:cNvPr id="1" name="TextBox 3"/>
+          <p:cNvSpPr txBox="1"/>
+          <p:nvPr/>
+        </p:nvSpPr>
+        <p:spPr>
+          <a:xfrm>
+            <a:off x="3568700" y="4076700"/>
+            <a:ext cx="5105400" cy="508000"/>
+          </a:xfrm>
+          <a:prstGeom prst="rect">
+            <a:avLst/>
+          </a:prstGeom>
+          <a:noFill/>
+        </p:spPr>
+        <p:txBody>
+          <a:bodyPr/>
+          <a:lstStyle/>
+          <a:p>
+            <a:pPr lvl="0" indent="0" marL="0" algn="ctr">
+              <a:buNone/>
+            </a:pPr>
+            <a:r>
+              <a:rPr/>
+              <a:t>Quadratic equation destroyed by reflow</a:t>
+            </a:r>
+          </a:p>
+        </p:txBody>
+      </p:sp>
     </p:spTree>
   </p:cSld>
 </p:sld>

</xml_diff>

<commit_message>
Adding in AM's image guidelines
</commit_message>
<xml_diff>
--- a/QuickIntroAccessibleMaths.pptx
+++ b/QuickIntroAccessibleMaths.pptx
@@ -4484,57 +4484,43 @@
               <a:rPr>
                 <a:hlinkClick r:id="rId9"/>
               </a:rPr>
-              <a:t>DIAGRAM Center</a:t>
-            </a:r>
-            <a:r>
-              <a:rPr/>
-              <a:t> has some great resources for those new to diagram description:</a:t>
-            </a:r>
-          </a:p>
-          <a:p>
-            <a:pPr lvl="2"/>
-            <a:r>
-              <a:rPr/>
-              <a:t>Poet Image Description Training Tool</a:t>
-            </a:r>
-          </a:p>
-          <a:p>
-            <a:pPr lvl="2"/>
-            <a:r>
-              <a:rPr/>
-              <a:t>Image description guidelines</a:t>
-            </a:r>
-          </a:p>
-          <a:p>
-            <a:pPr lvl="2"/>
-            <a:r>
-              <a:rPr/>
-              <a:t>Sample book</a:t>
-            </a:r>
-          </a:p>
-          <a:p>
-            <a:pPr lvl="2"/>
+              <a:t>Complex images - making sense for accessibility</a:t>
+            </a:r>
+          </a:p>
+          <a:p>
+            <a:pPr lvl="1"/>
             <a:r>
               <a:rPr>
                 <a:hlinkClick r:id="rId10"/>
               </a:rPr>
-              <a:t>Webinar on complex images</a:t>
-            </a:r>
-          </a:p>
-          <a:p>
-            <a:pPr lvl="0"/>
-            <a:r>
-              <a:rPr/>
-              <a:t>Maths e-assessment</a:t>
-            </a:r>
-          </a:p>
-          <a:p>
-            <a:pPr lvl="1"/>
+              <a:t>DIAGRAM Center</a:t>
+            </a:r>
+            <a:r>
+              <a:rPr/>
+              <a:t> has some great resources for those new to diagram description:</a:t>
+            </a:r>
+          </a:p>
+          <a:p>
+            <a:pPr lvl="2"/>
+            <a:r>
+              <a:rPr/>
+              <a:t>Poet Image Description Training Tool, Image description guidelines and Sample book</a:t>
+            </a:r>
+          </a:p>
+          <a:p>
+            <a:pPr lvl="2"/>
             <a:r>
               <a:rPr>
                 <a:hlinkClick r:id="rId11"/>
               </a:rPr>
-              <a:t>Numbas aims to meet WCAG 2.1 AA</a:t>
+              <a:t>Webinar on complex images</a:t>
+            </a:r>
+          </a:p>
+          <a:p>
+            <a:pPr lvl="0"/>
+            <a:r>
+              <a:rPr/>
+              <a:t>Maths e-assessment</a:t>
             </a:r>
           </a:p>
           <a:p>
@@ -4542,6 +4528,15 @@
             <a:r>
               <a:rPr>
                 <a:hlinkClick r:id="rId12"/>
+              </a:rPr>
+              <a:t>Numbas aims to meet WCAG 2.1 AA</a:t>
+            </a:r>
+          </a:p>
+          <a:p>
+            <a:pPr lvl="1"/>
+            <a:r>
+              <a:rPr>
+                <a:hlinkClick r:id="rId13"/>
               </a:rPr>
               <a:t>Stack aims to meet WCAG 2.1 AA</a:t>
             </a:r>

</xml_diff>